<commit_message>
Generated presentation and evidence files
</commit_message>
<xml_diff>
--- a/output/presentation.pptx
+++ b/output/presentation.pptx
@@ -2379,7 +2379,7 @@
                 <a:ea typeface="Cambria" pitchFamily="34" charset="-122"/>
                 <a:cs typeface="Cambria" pitchFamily="34" charset="-120"/>
               </a:rPr>
-              <a:t>NovaRetail Achieves Steady Growth Amid Regional Operational Risks</a:t>
+              <a:t>NovaRetail Achieves Solid Growth Amid Regional Operational Risks</a:t>
             </a:r>
             <a:endParaRPr lang="en-US" sz="2900" dirty="0" b="1" i="0">
               <a:latin typeface="Cambria"/>
@@ -2425,7 +2425,7 @@
                 <a:ea typeface="Calibri" pitchFamily="34" charset="-122"/>
                 <a:cs typeface="Calibri" pitchFamily="34" charset="-120"/>
               </a:rPr>
-              <a:t>2026-Q2 | Board Review | Prepared 2026-10-07</a:t>
+              <a:t>2026-Q2 | Board Review | Prepared 2026-10-08</a:t>
             </a:r>
             <a:endParaRPr lang="en-US" sz="1500" dirty="0" b="0" i="0">
               <a:latin typeface="Calibri"/>
@@ -2864,7 +2864,7 @@
                 <a:ea typeface="Calibri" pitchFamily="34" charset="-122"/>
                 <a:cs typeface="Calibri" pitchFamily="34" charset="-120"/>
               </a:rPr>
-              <a:t>NovaRetail achieved total revenue of 1280.0 million USD in 2026-Q2, representing 4.49 percent QoQ growth. While APAC led expansion with 26.92 percent revenue growth since 2025-Q3, Latin America experienced a 6.67 percent revenue decline. Operational risks present the biggest threat, as Latin America delivery times rose by 2.0 days and fraud incidents increased by 12.</a:t>
+              <a:t>NovaRetail delivered 4.49% QoQ revenue growth to reach 1280.0 million USD in 2026-Q2, driven by strong performance in North America and APAC. APAC represents our largest expansion opportunity, with revenue growing 26.92% since 2025-Q3. However, severe operational risks in Latin America, where delivery times increased by 2.0 days and NPS dropped by 9.0 points, threaten overall performance.</a:t>
             </a:r>
             <a:endParaRPr lang="en-US" sz="1800" dirty="0" b="0" i="0">
               <a:latin typeface="Calibri"/>
@@ -3058,7 +3058,7 @@
                 <a:ea typeface="Cambria" pitchFamily="34" charset="-122"/>
                 <a:cs typeface="Cambria" pitchFamily="34" charset="-120"/>
               </a:rPr>
-              <a:t>Revenue Expansion Led by APAC and North America</a:t>
+              <a:t>Strong Revenue Growth Led by North America and APAC</a:t>
             </a:r>
             <a:endParaRPr lang="en-US" sz="2400" dirty="0" b="1" i="0">
               <a:latin typeface="Cambria"/>
@@ -3104,7 +3104,7 @@
                 <a:ea typeface="Calibri" pitchFamily="34" charset="-122"/>
                 <a:cs typeface="Calibri" pitchFamily="34" charset="-120"/>
               </a:rPr>
-              <a:t>Total revenue reached 1280.0 million USD in 2026-Q2, growing 4.49 percent QoQ from the previous quarter.</a:t>
+              <a:t>Total revenue reached 1280.0 million USD in 2026-Q2, representing a solid 4.49% QoQ growth rate.</a:t>
             </a:r>
             <a:endParaRPr lang="en-US" sz="1300" dirty="0" b="0" i="0">
               <a:latin typeface="Calibri"/>
@@ -3126,7 +3126,7 @@
                 <a:ea typeface="Calibri" pitchFamily="34" charset="-122"/>
                 <a:cs typeface="Calibri" pitchFamily="34" charset="-120"/>
               </a:rPr>
-              <a:t>APAC revenue grew by 26.92 percent from 2025-Q3 to 2026-Q2, reaching 330.0 million USD.</a:t>
+              <a:t>North America remains our largest market, growing revenue by 10.71% to 465.0 million USD since 2025-Q3.</a:t>
             </a:r>
             <a:endParaRPr sz="1300" b="0" i="0">
               <a:latin typeface="Calibri"/>
@@ -3148,7 +3148,7 @@
                 <a:ea typeface="Calibri" pitchFamily="34" charset="-122"/>
                 <a:cs typeface="Calibri" pitchFamily="34" charset="-120"/>
               </a:rPr>
-              <a:t>North America remains the top revenue contributor, increasing by 45.0 million USD to 465.0 million USD.</a:t>
+              <a:t>APAC led expansion with 26.92% revenue growth, rising from 260.0 million USD to 330.0 million USD.</a:t>
             </a:r>
             <a:endParaRPr sz="1300" b="0" i="0">
               <a:latin typeface="Calibri"/>
@@ -3170,7 +3170,7 @@
                 <a:ea typeface="Calibri" pitchFamily="34" charset="-122"/>
                 <a:cs typeface="Calibri" pitchFamily="34" charset="-120"/>
               </a:rPr>
-              <a:t>Latin America revenue declined by 6.67 percent, falling from 150.0 million USD to 140.0 million USD.</a:t>
+              <a:t>Latin America revenue declined by 6.67% to 140.0 million USD since 2025-Q3, reflecting severe operational headwinds.</a:t>
             </a:r>
             <a:endParaRPr sz="1300" b="0" i="0">
               <a:latin typeface="Calibri"/>
@@ -3382,7 +3382,7 @@
                 <a:ea typeface="Cambria" pitchFamily="34" charset="-122"/>
                 <a:cs typeface="Cambria" pitchFamily="34" charset="-120"/>
               </a:rPr>
-              <a:t>Customer Experience Diverges Across Key Regions</a:t>
+              <a:t>Customer Satisfaction Rises Globally Except in Latin America</a:t>
             </a:r>
             <a:endParaRPr lang="en-US" sz="2400" dirty="0" b="1" i="0">
               <a:latin typeface="Cambria"/>
@@ -3428,7 +3428,7 @@
                 <a:ea typeface="Calibri" pitchFamily="34" charset="-122"/>
                 <a:cs typeface="Calibri" pitchFamily="34" charset="-120"/>
               </a:rPr>
-              <a:t>Mean regional NPS stands at 49.75 points, with APAC leading at 62.0 points in 2026-Q2.</a:t>
+              <a:t>Unweighted regional NPS stands at 49.75 points, with APAC leading customer satisfaction at 62.0 points.</a:t>
             </a:r>
             <a:endParaRPr lang="en-US" sz="1300" dirty="0" b="0" i="0">
               <a:latin typeface="Calibri"/>
@@ -3450,7 +3450,7 @@
                 <a:ea typeface="Calibri" pitchFamily="34" charset="-122"/>
                 <a:cs typeface="Calibri" pitchFamily="34" charset="-120"/>
               </a:rPr>
-              <a:t>Latin America NPS fell by 9.0 points to 29.0 points, while CSAT decreased by 6.0 percentage points.</a:t>
+              <a:t>Europe improved customer sentiment, increasing NPS by 5.0 points and CSAT by 2.0 percentage points since 2025-Q3.</a:t>
             </a:r>
             <a:endParaRPr sz="1300" b="0" i="0">
               <a:latin typeface="Calibri"/>
@@ -3472,7 +3472,7 @@
                 <a:ea typeface="Calibri" pitchFamily="34" charset="-122"/>
                 <a:cs typeface="Calibri" pitchFamily="34" charset="-120"/>
               </a:rPr>
-              <a:t>Europe improved customer satisfaction, raising NPS by 5.0 points and CSAT by 2.0 percentage points.</a:t>
+              <a:t>North America customer metrics improved, with NPS rising 3.0 points to reach 55.0 points since 2025-Q3.</a:t>
             </a:r>
             <a:endParaRPr sz="1300" b="0" i="0">
               <a:latin typeface="Calibri"/>
@@ -3494,7 +3494,7 @@
                 <a:ea typeface="Calibri" pitchFamily="34" charset="-122"/>
                 <a:cs typeface="Calibri" pitchFamily="34" charset="-120"/>
               </a:rPr>
-              <a:t>North America customer metrics improved slightly, with NPS rising by 3.0 points to 55.0 points.</a:t>
+              <a:t>Latin America NPS dropped 9.0 points and CSAT fell 6.0 percentage points since 2025-Q3, showing deteriorated sentiment.</a:t>
             </a:r>
             <a:endParaRPr sz="1300" b="0" i="0">
               <a:latin typeface="Calibri"/>
@@ -3706,7 +3706,7 @@
                 <a:ea typeface="Cambria" pitchFamily="34" charset="-122"/>
                 <a:cs typeface="Cambria" pitchFamily="34" charset="-120"/>
               </a:rPr>
-              <a:t>Operational Risks and Supply Chain Constraints Intensify</a:t>
+              <a:t>Rising Supply Chain and Fraud Risks Threaten Operations</a:t>
             </a:r>
             <a:endParaRPr lang="en-US" sz="2400" dirty="0" b="1" i="0">
               <a:latin typeface="Cambria"/>
@@ -3752,7 +3752,7 @@
                 <a:ea typeface="Calibri" pitchFamily="34" charset="-122"/>
                 <a:cs typeface="Calibri" pitchFamily="34" charset="-120"/>
               </a:rPr>
-              <a:t>Latin America delivery times increased by 2.0 days, while support tickets surged by 11.0K.</a:t>
+              <a:t>Latin America delivery times increased by 2.0 days to 7.5 days since 2025-Q3, indicating severe operational risks.</a:t>
             </a:r>
             <a:endParaRPr lang="en-US" sz="1300" dirty="0" b="0" i="0">
               <a:latin typeface="Calibri"/>
@@ -3774,7 +3774,7 @@
                 <a:ea typeface="Calibri" pitchFamily="34" charset="-122"/>
                 <a:cs typeface="Calibri" pitchFamily="34" charset="-120"/>
               </a:rPr>
-              <a:t>Fraud incidents in Latin America rose from 18 to 30, representing a significant security risk.</a:t>
+              <a:t>Fraud incidents in Latin America surged by 12 cases to 30.0 incidents since 2025-Q3, posing security threats.</a:t>
             </a:r>
             <a:endParaRPr sz="1300" b="0" i="0">
               <a:latin typeface="Calibri"/>
@@ -3796,7 +3796,7 @@
                 <a:ea typeface="Calibri" pitchFamily="34" charset="-122"/>
                 <a:cs typeface="Calibri" pitchFamily="34" charset="-120"/>
               </a:rPr>
-              <a:t>APAC warehouse capacity utilization reached 92.0 percent, while stockout rates increased by 2.5 percentage points.</a:t>
+              <a:t>APAC warehouse capacity utilization reached 92.0%, driving stockout rates up by 2.5 percentage points since 2025-Q3.</a:t>
             </a:r>
             <a:endParaRPr sz="1300" b="0" i="0">
               <a:latin typeface="Calibri"/>
@@ -3818,7 +3818,7 @@
                 <a:ea typeface="Calibri" pitchFamily="34" charset="-122"/>
                 <a:cs typeface="Calibri" pitchFamily="34" charset="-120"/>
               </a:rPr>
-              <a:t>Returns rate in Latin America increased by 1.7 percentage points, reaching 8.2 percent in 2026-Q2.</a:t>
+              <a:t>Support tickets in Latin America spiked by 11.0K since 2025-Q3, reflecting growing customer frustration with delays.</a:t>
             </a:r>
             <a:endParaRPr sz="1300" b="0" i="0">
               <a:latin typeface="Calibri"/>
@@ -4030,7 +4030,7 @@
                 <a:ea typeface="Cambria" pitchFamily="34" charset="-122"/>
                 <a:cs typeface="Cambria" pitchFamily="34" charset="-120"/>
               </a:rPr>
-              <a:t>Recommended Actions to Address Operational Bottlenecks</a:t>
+              <a:t>Strategic Recommendations to Mitigate Risk and Support Growth</a:t>
             </a:r>
             <a:endParaRPr lang="en-US" sz="2800" dirty="0" b="1" i="0">
               <a:latin typeface="Cambria"/>
@@ -4076,7 +4076,7 @@
                 <a:ea typeface="Calibri" pitchFamily="34" charset="-122"/>
                 <a:cs typeface="Calibri" pitchFamily="34" charset="-120"/>
               </a:rPr>
-              <a:t>Expand</a:t>
+              <a:t>Optimize</a:t>
             </a:r>
             <a:r>
               <a:rPr lang="en-US" sz="1600" i="0" dirty="0" b="0">
@@ -4087,7 +4087,7 @@
                 <a:ea typeface="Calibri" pitchFamily="34" charset="-122"/>
                 <a:cs typeface="Calibri" pitchFamily="34" charset="-120"/>
               </a:rPr>
-              <a:t> warehouse capacity in APAC to address the 92.0 percent utilization rate and rising stockouts.</a:t>
+              <a:t> Latin America logistics to reduce the 7.5-day delivery average and lower the 31.0K support tickets.</a:t>
             </a:r>
             <a:endParaRPr lang="en-US" sz="1600" dirty="0" b="0" i="0">
               <a:latin typeface="Calibri"/>
@@ -4109,7 +4109,7 @@
                 <a:ea typeface="Calibri" pitchFamily="34" charset="-122"/>
                 <a:cs typeface="Calibri" pitchFamily="34" charset="-120"/>
               </a:rPr>
-              <a:t>Implement</a:t>
+              <a:t>Deploy</a:t>
             </a:r>
             <a:r>
               <a:rPr lang="en-US" sz="1600" i="0" dirty="0" b="0">
@@ -4120,7 +4120,7 @@
                 <a:ea typeface="Calibri" pitchFamily="34" charset="-122"/>
                 <a:cs typeface="Calibri" pitchFamily="34" charset="-120"/>
               </a:rPr>
-              <a:t> fraud prevention measures in Latin America to address the rise to 30 fraud incidents.</a:t>
+              <a:t> fraud prevention measures in Latin America to address the surge to 30.0 incidents since 2025-Q3.</a:t>
             </a:r>
             <a:endParaRPr sz="1600" b="0" i="0">
               <a:latin typeface="Calibri"/>
@@ -4142,7 +4142,7 @@
                 <a:ea typeface="Calibri" pitchFamily="34" charset="-122"/>
                 <a:cs typeface="Calibri" pitchFamily="34" charset="-120"/>
               </a:rPr>
-              <a:t>Optimize</a:t>
+              <a:t>Expand</a:t>
             </a:r>
             <a:r>
               <a:rPr lang="en-US" sz="1600" i="0" dirty="0" b="0">
@@ -4153,7 +4153,7 @@
                 <a:ea typeface="Calibri" pitchFamily="34" charset="-122"/>
                 <a:cs typeface="Calibri" pitchFamily="34" charset="-120"/>
               </a:rPr>
-              <a:t> Latin America logistics to reduce delivery times, which increased by 2.0 days since 2025-Q3.</a:t>
+              <a:t> APAC warehouse capacity to relieve the 92.0% utilization rate and mitigate the 8.5% stockout rate.</a:t>
             </a:r>
             <a:endParaRPr sz="1600" b="0" i="0">
               <a:latin typeface="Calibri"/>
@@ -4175,7 +4175,7 @@
                 <a:ea typeface="Calibri" pitchFamily="34" charset="-122"/>
                 <a:cs typeface="Calibri" pitchFamily="34" charset="-120"/>
               </a:rPr>
-              <a:t>Streamline</a:t>
+              <a:t>Standardize</a:t>
             </a:r>
             <a:r>
               <a:rPr lang="en-US" sz="1600" i="0" dirty="0" b="0">
@@ -4186,7 +4186,7 @@
                 <a:ea typeface="Calibri" pitchFamily="34" charset="-122"/>
                 <a:cs typeface="Calibri" pitchFamily="34" charset="-120"/>
               </a:rPr>
-              <a:t> return processing in APAC to reduce processing times, which rose by 1.0 days.</a:t>
+              <a:t> European return processes to maintain the stable 5.0-day processing time and support NPS growth.</a:t>
             </a:r>
             <a:endParaRPr sz="1600" b="0" i="0">
               <a:latin typeface="Calibri"/>
@@ -4232,7 +4232,7 @@
                 <a:ea typeface="Calibri" pitchFamily="34" charset="-122"/>
                 <a:cs typeface="Calibri" pitchFamily="34" charset="-120"/>
               </a:rPr>
-              <a:t>Addressing these operational challenges will help stabilize Latin America and sustain APAC growth.</a:t>
+              <a:t>Addressing these critical operational bottlenecks will safeguard NovaRetail's growth trajectory and protect customer loyalty.</a:t>
             </a:r>
             <a:endParaRPr lang="en-US" sz="1400" dirty="0" b="0" i="0">
               <a:latin typeface="Calibri"/>

</xml_diff>